<commit_message>
Refresh the figures quoted in README and deck
Both quoted the 18-scenario numbers. Now 21/21, mean 108.1, 242 tests.

The deck script was briefly corrupted by editing it through PowerShell
Set-Content, which round-trips UTF-8 through the ANSI codepage and turned every
em-dash into mojibake. Reverted and redone with proper edits; markitdown
confirms the packed .pptx is clean.
</commit_message>
<xml_diff>
--- a/deck/ThaparPatiala_TEAM_Submission_ppt.pptx
+++ b/deck/ThaparPatiala_TEAM_Submission_ppt.pptx
@@ -10974,7 +10974,7 @@
                 <a:ea typeface="Cambria" pitchFamily="34" charset="-122"/>
                 <a:cs typeface="Cambria" pitchFamily="34" charset="-120"/>
               </a:rPr>
-              <a:t>18/18</a:t>
+              <a:t>21/21</a:t>
             </a:r>
             <a:endParaRPr lang="en-US" sz="4600" dirty="0"/>
           </a:p>
@@ -11069,7 +11069,7 @@
                 <a:ea typeface="Cambria" pitchFamily="34" charset="-122"/>
                 <a:cs typeface="Cambria" pitchFamily="34" charset="-120"/>
               </a:rPr>
-              <a:t>107.8</a:t>
+              <a:t>108.1</a:t>
             </a:r>
             <a:endParaRPr lang="en-US" sz="4600" dirty="0"/>
           </a:p>
@@ -11259,7 +11259,7 @@
                 <a:ea typeface="Cambria" pitchFamily="34" charset="-122"/>
                 <a:cs typeface="Cambria" pitchFamily="34" charset="-120"/>
               </a:rPr>
-              <a:t>233</a:t>
+              <a:t>242</a:t>
             </a:r>
             <a:endParaRPr lang="en-US" sz="4600" dirty="0"/>
           </a:p>
@@ -12258,7 +12258,7 @@
                 <a:ea typeface="Calibri" pitchFamily="34" charset="-122"/>
                 <a:cs typeface="Calibri" pitchFamily="34" charset="-120"/>
               </a:rPr>
-              <a:t>9 scenarios</a:t>
+              <a:t>12 scenarios</a:t>
             </a:r>
             <a:endParaRPr lang="en-US" sz="1100" dirty="0"/>
           </a:p>
@@ -12297,7 +12297,7 @@
                 <a:ea typeface="Calibri" pitchFamily="34" charset="-122"/>
                 <a:cs typeface="Calibri" pitchFamily="34" charset="-120"/>
               </a:rPr>
-              <a:t>110.6</a:t>
+              <a:t>110.4</a:t>
             </a:r>
             <a:endParaRPr lang="en-US" sz="1300" dirty="0"/>
           </a:p>
@@ -12624,7 +12624,7 @@
                 <a:ea typeface="Calibri" pitchFamily="34" charset="-122"/>
                 <a:cs typeface="Calibri" pitchFamily="34" charset="-120"/>
               </a:rPr>
-              <a:t>Suite mix: 50% text / 28% audio / 22% visual, matching the published set.</a:t>
+              <a:t>21 scenarios: 57% text / 24% audio / 19% visual.</a:t>
             </a:r>
             <a:endParaRPr lang="en-US" sz="1050" dirty="0"/>
           </a:p>
@@ -12776,7 +12776,7 @@
                 <a:ea typeface="Calibri" pitchFamily="34" charset="-122"/>
                 <a:cs typeface="Calibri" pitchFamily="34" charset="-120"/>
               </a:rPr>
-              <a:t>The hidden set is ~60 scenarios of “edge cases and adversarial timing”. Passing the eighteen we wrote proves little — they are the cases we thought of. So the fuzzer jitters timestamps, scales tool latency, moves commit points, collapses events onto identical timestamps, injects faults and truncates sessions — then asserts only invariants, never expectations.</a:t>
+              <a:t>The hidden set is ~60 scenarios of “edge cases and adversarial timing”. Passing the twenty-one we wrote proves little — they are the cases we thought of. So the fuzzer jitters timestamps, scales tool latency, moves commit points, collapses events onto identical timestamps, injects faults and truncates sessions — then asserts only invariants, never expectations.</a:t>
             </a:r>
             <a:endParaRPr lang="en-US" sz="1500" dirty="0"/>
           </a:p>

</xml_diff>

<commit_message>
Refresh deck figures: 22/22, mean 109.5, 254 tests
</commit_message>
<xml_diff>
--- a/deck/ThaparPatiala_TEAM_Submission_ppt.pptx
+++ b/deck/ThaparPatiala_TEAM_Submission_ppt.pptx
@@ -10974,7 +10974,7 @@
                 <a:ea typeface="Cambria" pitchFamily="34" charset="-122"/>
                 <a:cs typeface="Cambria" pitchFamily="34" charset="-120"/>
               </a:rPr>
-              <a:t>21/21</a:t>
+              <a:t>22/22</a:t>
             </a:r>
             <a:endParaRPr lang="en-US" sz="4600" dirty="0"/>
           </a:p>
@@ -11069,7 +11069,7 @@
                 <a:ea typeface="Cambria" pitchFamily="34" charset="-122"/>
                 <a:cs typeface="Cambria" pitchFamily="34" charset="-120"/>
               </a:rPr>
-              <a:t>108.1</a:t>
+              <a:t>109.5</a:t>
             </a:r>
             <a:endParaRPr lang="en-US" sz="4600" dirty="0"/>
           </a:p>
@@ -11164,7 +11164,7 @@
                 <a:ea typeface="Cambria" pitchFamily="34" charset="-122"/>
                 <a:cs typeface="Cambria" pitchFamily="34" charset="-120"/>
               </a:rPr>
-              <a:t>4500</a:t>
+              <a:t>1980</a:t>
             </a:r>
             <a:endParaRPr lang="en-US" sz="4600" dirty="0"/>
           </a:p>
@@ -11259,7 +11259,7 @@
                 <a:ea typeface="Cambria" pitchFamily="34" charset="-122"/>
                 <a:cs typeface="Cambria" pitchFamily="34" charset="-120"/>
               </a:rPr>
-              <a:t>242</a:t>
+              <a:t>254</a:t>
             </a:r>
             <a:endParaRPr lang="en-US" sz="4600" dirty="0"/>
           </a:p>
@@ -12258,7 +12258,7 @@
                 <a:ea typeface="Calibri" pitchFamily="34" charset="-122"/>
                 <a:cs typeface="Calibri" pitchFamily="34" charset="-120"/>
               </a:rPr>
-              <a:t>12 scenarios</a:t>
+              <a:t>13 scenarios</a:t>
             </a:r>
             <a:endParaRPr lang="en-US" sz="1100" dirty="0"/>
           </a:p>
@@ -12441,7 +12441,7 @@
                 <a:ea typeface="Calibri" pitchFamily="34" charset="-122"/>
                 <a:cs typeface="Calibri" pitchFamily="34" charset="-120"/>
               </a:rPr>
-              <a:t>104.0</a:t>
+              <a:t>108.0</a:t>
             </a:r>
             <a:endParaRPr lang="en-US" sz="1300" dirty="0"/>
           </a:p>
@@ -12585,7 +12585,7 @@
                 <a:ea typeface="Calibri" pitchFamily="34" charset="-122"/>
                 <a:cs typeface="Calibri" pitchFamily="34" charset="-120"/>
               </a:rPr>
-              <a:t>106.2</a:t>
+              <a:t>108.8</a:t>
             </a:r>
             <a:endParaRPr lang="en-US" sz="1300" dirty="0"/>
           </a:p>
@@ -12624,7 +12624,7 @@
                 <a:ea typeface="Calibri" pitchFamily="34" charset="-122"/>
                 <a:cs typeface="Calibri" pitchFamily="34" charset="-120"/>
               </a:rPr>
-              <a:t>21 scenarios: 57% text / 24% audio / 19% visual.</a:t>
+              <a:t>22 scenarios: 59% text / 23% audio / 18% visual.</a:t>
             </a:r>
             <a:endParaRPr lang="en-US" sz="1050" dirty="0"/>
           </a:p>
@@ -12776,7 +12776,7 @@
                 <a:ea typeface="Calibri" pitchFamily="34" charset="-122"/>
                 <a:cs typeface="Calibri" pitchFamily="34" charset="-120"/>
               </a:rPr>
-              <a:t>The hidden set is ~60 scenarios of “edge cases and adversarial timing”. Passing the twenty-one we wrote proves little — they are the cases we thought of. So the fuzzer jitters timestamps, scales tool latency, moves commit points, collapses events onto identical timestamps, injects faults and truncates sessions — then asserts only invariants, never expectations.</a:t>
+              <a:t>The hidden set is ~60 scenarios of “edge cases and adversarial timing”. Passing the twenty-two we wrote proves little — they are the cases we thought of. So the fuzzer jitters timestamps, scales tool latency, moves commit points, collapses events onto identical timestamps, injects faults and truncates sessions — then asserts only invariants, never expectations.</a:t>
             </a:r>
             <a:endParaRPr lang="en-US" sz="1500" dirty="0"/>
           </a:p>
@@ -13573,7 +13573,7 @@
                 <a:ea typeface="Calibri" pitchFamily="34" charset="-122"/>
                 <a:cs typeface="Calibri" pitchFamily="34" charset="-120"/>
               </a:rPr>
-              <a:t>4500 / 4500 held, at ±1400 ms jitter.</a:t>
+              <a:t>Every run held, across thousands of schedules.</a:t>
             </a:r>
             <a:endParaRPr lang="en-US" sz="1300" dirty="0"/>
           </a:p>

</xml_diff>